<commit_message>
Update web UI to clean, minimal white theme and add LabView VI
</commit_message>
<xml_diff>
--- a/Documentaion/Cascade (Dual-Loop) Voltage-Current Control of a Buck Converter.pptx
+++ b/Documentaion/Cascade (Dual-Loop) Voltage-Current Control of a Buck Converter.pptx
@@ -121,7 +121,136 @@
       </a:defRPr>
     </a:lvl9pPr>
   </p:defaultTextStyle>
+  <p:extLst>
+    <p:ext uri="{EFAFB233-063F-42B5-8137-9DF3F51BA10A}">
+      <p15:sldGuideLst xmlns:p15="http://schemas.microsoft.com/office/powerpoint/2012/main"/>
+    </p:ext>
+  </p:extLst>
 </p:presentation>
+</file>
+
+<file path=ppt/revisionInfo.xml><?xml version="1.0" encoding="utf-8"?>
+<p1510:revInfo xmlns:a="http://schemas.openxmlformats.org/drawingml/2006/main" xmlns:r="http://schemas.openxmlformats.org/officeDocument/2006/relationships" xmlns:p1510="http://schemas.microsoft.com/office/powerpoint/2015/10/main">
+  <p1510:revLst>
+    <p1510:client id="{0F2F3958-672B-439F-87C8-6B013C0036A0}" v="7" dt="2026-08-25T18:48:26.882"/>
+  </p1510:revLst>
+</p1510:revInfo>
+</file>
+
+<file path=ppt/changesInfos/changesInfo1.xml><?xml version="1.0" encoding="utf-8"?>
+<pc:chgInfo xmlns:a="http://schemas.openxmlformats.org/drawingml/2006/main" xmlns:r="http://schemas.openxmlformats.org/officeDocument/2006/relationships" xmlns:ac="http://schemas.microsoft.com/office/drawing/2013/main/command" xmlns:pc="http://schemas.microsoft.com/office/powerpoint/2013/main/command">
+  <pc:docChgLst>
+    <pc:chgData name="Hitesh VS" userId="43e83e4b074d8f7c" providerId="LiveId" clId="{634118E8-76C5-4A74-927B-F9C275DB7B49}"/>
+    <pc:docChg chg="custSel modSld">
+      <pc:chgData name="Hitesh VS" userId="43e83e4b074d8f7c" providerId="LiveId" clId="{634118E8-76C5-4A74-927B-F9C275DB7B49}" dt="2026-08-25T18:48:30.931" v="39" actId="1076"/>
+      <pc:docMkLst>
+        <pc:docMk/>
+      </pc:docMkLst>
+      <pc:sldChg chg="addSp delSp modSp mod">
+        <pc:chgData name="Hitesh VS" userId="43e83e4b074d8f7c" providerId="LiveId" clId="{634118E8-76C5-4A74-927B-F9C275DB7B49}" dt="2026-08-25T18:48:30.931" v="39" actId="1076"/>
+        <pc:sldMkLst>
+          <pc:docMk/>
+          <pc:sldMk cId="379672822" sldId="268"/>
+        </pc:sldMkLst>
+        <pc:spChg chg="add del mod">
+          <ac:chgData name="Hitesh VS" userId="43e83e4b074d8f7c" providerId="LiveId" clId="{634118E8-76C5-4A74-927B-F9C275DB7B49}" dt="2026-08-25T18:48:27.800" v="37"/>
+          <ac:spMkLst>
+            <pc:docMk/>
+            <pc:sldMk cId="379672822" sldId="268"/>
+            <ac:spMk id="4" creationId="{21E57D5B-00B5-BF38-89A3-5B077169AFF5}"/>
+          </ac:spMkLst>
+        </pc:spChg>
+        <pc:spChg chg="add mod">
+          <ac:chgData name="Hitesh VS" userId="43e83e4b074d8f7c" providerId="LiveId" clId="{634118E8-76C5-4A74-927B-F9C275DB7B49}" dt="2026-08-25T18:48:30.931" v="39" actId="1076"/>
+          <ac:spMkLst>
+            <pc:docMk/>
+            <pc:sldMk cId="379672822" sldId="268"/>
+            <ac:spMk id="8" creationId="{1FFEF2B4-8A3E-CAA0-E7EB-10F10E198A50}"/>
+          </ac:spMkLst>
+        </pc:spChg>
+        <pc:picChg chg="add mod">
+          <ac:chgData name="Hitesh VS" userId="43e83e4b074d8f7c" providerId="LiveId" clId="{634118E8-76C5-4A74-927B-F9C275DB7B49}" dt="2026-08-25T18:48:21.253" v="34" actId="1076"/>
+          <ac:picMkLst>
+            <pc:docMk/>
+            <pc:sldMk cId="379672822" sldId="268"/>
+            <ac:picMk id="3" creationId="{71D159D8-857C-1612-EB5F-5694F115D5A2}"/>
+          </ac:picMkLst>
+        </pc:picChg>
+        <pc:picChg chg="del">
+          <ac:chgData name="Hitesh VS" userId="43e83e4b074d8f7c" providerId="LiveId" clId="{634118E8-76C5-4A74-927B-F9C275DB7B49}" dt="2026-08-25T18:45:41.731" v="0" actId="478"/>
+          <ac:picMkLst>
+            <pc:docMk/>
+            <pc:sldMk cId="379672822" sldId="268"/>
+            <ac:picMk id="5" creationId="{374806D8-A4D2-D3DC-5CB8-AA81E0E0891B}"/>
+          </ac:picMkLst>
+        </pc:picChg>
+        <pc:picChg chg="del">
+          <ac:chgData name="Hitesh VS" userId="43e83e4b074d8f7c" providerId="LiveId" clId="{634118E8-76C5-4A74-927B-F9C275DB7B49}" dt="2026-08-25T18:45:42.273" v="1" actId="478"/>
+          <ac:picMkLst>
+            <pc:docMk/>
+            <pc:sldMk cId="379672822" sldId="268"/>
+            <ac:picMk id="7" creationId="{C2D3265C-6CEB-F4D7-45EA-5124C7CE2218}"/>
+          </ac:picMkLst>
+        </pc:picChg>
+        <pc:picChg chg="del">
+          <ac:chgData name="Hitesh VS" userId="43e83e4b074d8f7c" providerId="LiveId" clId="{634118E8-76C5-4A74-927B-F9C275DB7B49}" dt="2026-08-25T18:45:42.851" v="2" actId="478"/>
+          <ac:picMkLst>
+            <pc:docMk/>
+            <pc:sldMk cId="379672822" sldId="268"/>
+            <ac:picMk id="9" creationId="{1A637697-2FB7-FD0E-7BB8-CFD1830432F8}"/>
+          </ac:picMkLst>
+        </pc:picChg>
+      </pc:sldChg>
+      <pc:sldChg chg="addSp delSp modSp mod">
+        <pc:chgData name="Hitesh VS" userId="43e83e4b074d8f7c" providerId="LiveId" clId="{634118E8-76C5-4A74-927B-F9C275DB7B49}" dt="2026-08-25T18:47:05.492" v="30"/>
+        <pc:sldMkLst>
+          <pc:docMk/>
+          <pc:sldMk cId="2307402334" sldId="269"/>
+        </pc:sldMkLst>
+        <pc:spChg chg="add mod">
+          <ac:chgData name="Hitesh VS" userId="43e83e4b074d8f7c" providerId="LiveId" clId="{634118E8-76C5-4A74-927B-F9C275DB7B49}" dt="2026-08-25T18:47:05.492" v="30"/>
+          <ac:spMkLst>
+            <pc:docMk/>
+            <pc:sldMk cId="2307402334" sldId="269"/>
+            <ac:spMk id="6" creationId="{8512C559-C20A-D34F-B82D-3262DF06B04A}"/>
+          </ac:spMkLst>
+        </pc:spChg>
+        <pc:picChg chg="del">
+          <ac:chgData name="Hitesh VS" userId="43e83e4b074d8f7c" providerId="LiveId" clId="{634118E8-76C5-4A74-927B-F9C275DB7B49}" dt="2026-08-25T18:45:45.542" v="3" actId="478"/>
+          <ac:picMkLst>
+            <pc:docMk/>
+            <pc:sldMk cId="2307402334" sldId="269"/>
+            <ac:picMk id="3" creationId="{B623D55B-B264-8050-306D-657136DF845B}"/>
+          </ac:picMkLst>
+        </pc:picChg>
+        <pc:picChg chg="add mod">
+          <ac:chgData name="Hitesh VS" userId="43e83e4b074d8f7c" providerId="LiveId" clId="{634118E8-76C5-4A74-927B-F9C275DB7B49}" dt="2026-08-25T18:45:50.291" v="7" actId="1076"/>
+          <ac:picMkLst>
+            <pc:docMk/>
+            <pc:sldMk cId="2307402334" sldId="269"/>
+            <ac:picMk id="4" creationId="{8524C895-0949-B225-A45D-A995C7E873A5}"/>
+          </ac:picMkLst>
+        </pc:picChg>
+        <pc:picChg chg="del">
+          <ac:chgData name="Hitesh VS" userId="43e83e4b074d8f7c" providerId="LiveId" clId="{634118E8-76C5-4A74-927B-F9C275DB7B49}" dt="2026-08-25T18:45:46.171" v="4" actId="478"/>
+          <ac:picMkLst>
+            <pc:docMk/>
+            <pc:sldMk cId="2307402334" sldId="269"/>
+            <ac:picMk id="5" creationId="{78A43E04-ADA9-BCC4-BA00-8F71ED898328}"/>
+          </ac:picMkLst>
+        </pc:picChg>
+        <pc:picChg chg="del">
+          <ac:chgData name="Hitesh VS" userId="43e83e4b074d8f7c" providerId="LiveId" clId="{634118E8-76C5-4A74-927B-F9C275DB7B49}" dt="2026-08-25T18:45:46.672" v="5" actId="478"/>
+          <ac:picMkLst>
+            <pc:docMk/>
+            <pc:sldMk cId="2307402334" sldId="269"/>
+            <ac:picMk id="7" creationId="{1575AAE5-9134-DC1D-7204-E4E1A8596AA5}"/>
+          </ac:picMkLst>
+        </pc:picChg>
+      </pc:sldChg>
+    </pc:docChg>
+  </pc:docChgLst>
+</pc:chgInfo>
 </file>
 
 <file path=ppt/notesMasters/notesMaster1.xml><?xml version="1.0" encoding="utf-8"?>
@@ -206,7 +335,7 @@
           <a:p>
             <a:fld id="{64BC94FC-8B81-4A05-AC3B-F37C36B793C0}" type="datetimeFigureOut">
               <a:rPr lang="en-IN" smtClean="0"/>
-              <a:t>21-08-2026</a:t>
+              <a:t>26-08-2026</a:t>
             </a:fld>
             <a:endParaRPr lang="en-IN"/>
           </a:p>
@@ -623,7 +752,7 @@
           <a:p>
             <a:fld id="{38D1EB97-86F8-4114-AC2B-0DF97BCDEC1A}" type="datetimeFigureOut">
               <a:rPr lang="en-IN" smtClean="0"/>
-              <a:t>21-08-2026</a:t>
+              <a:t>26-08-2026</a:t>
             </a:fld>
             <a:endParaRPr lang="en-IN"/>
           </a:p>
@@ -823,7 +952,7 @@
           <a:p>
             <a:fld id="{38D1EB97-86F8-4114-AC2B-0DF97BCDEC1A}" type="datetimeFigureOut">
               <a:rPr lang="en-IN" smtClean="0"/>
-              <a:t>21-08-2026</a:t>
+              <a:t>26-08-2026</a:t>
             </a:fld>
             <a:endParaRPr lang="en-IN"/>
           </a:p>
@@ -1033,7 +1162,7 @@
           <a:p>
             <a:fld id="{38D1EB97-86F8-4114-AC2B-0DF97BCDEC1A}" type="datetimeFigureOut">
               <a:rPr lang="en-IN" smtClean="0"/>
-              <a:t>21-08-2026</a:t>
+              <a:t>26-08-2026</a:t>
             </a:fld>
             <a:endParaRPr lang="en-IN"/>
           </a:p>
@@ -1233,7 +1362,7 @@
           <a:p>
             <a:fld id="{38D1EB97-86F8-4114-AC2B-0DF97BCDEC1A}" type="datetimeFigureOut">
               <a:rPr lang="en-IN" smtClean="0"/>
-              <a:t>21-08-2026</a:t>
+              <a:t>26-08-2026</a:t>
             </a:fld>
             <a:endParaRPr lang="en-IN"/>
           </a:p>
@@ -1509,7 +1638,7 @@
           <a:p>
             <a:fld id="{38D1EB97-86F8-4114-AC2B-0DF97BCDEC1A}" type="datetimeFigureOut">
               <a:rPr lang="en-IN" smtClean="0"/>
-              <a:t>21-08-2026</a:t>
+              <a:t>26-08-2026</a:t>
             </a:fld>
             <a:endParaRPr lang="en-IN"/>
           </a:p>
@@ -1777,7 +1906,7 @@
           <a:p>
             <a:fld id="{38D1EB97-86F8-4114-AC2B-0DF97BCDEC1A}" type="datetimeFigureOut">
               <a:rPr lang="en-IN" smtClean="0"/>
-              <a:t>21-08-2026</a:t>
+              <a:t>26-08-2026</a:t>
             </a:fld>
             <a:endParaRPr lang="en-IN"/>
           </a:p>
@@ -2192,7 +2321,7 @@
           <a:p>
             <a:fld id="{38D1EB97-86F8-4114-AC2B-0DF97BCDEC1A}" type="datetimeFigureOut">
               <a:rPr lang="en-IN" smtClean="0"/>
-              <a:t>21-08-2026</a:t>
+              <a:t>26-08-2026</a:t>
             </a:fld>
             <a:endParaRPr lang="en-IN"/>
           </a:p>
@@ -2334,7 +2463,7 @@
           <a:p>
             <a:fld id="{38D1EB97-86F8-4114-AC2B-0DF97BCDEC1A}" type="datetimeFigureOut">
               <a:rPr lang="en-IN" smtClean="0"/>
-              <a:t>21-08-2026</a:t>
+              <a:t>26-08-2026</a:t>
             </a:fld>
             <a:endParaRPr lang="en-IN"/>
           </a:p>
@@ -2447,7 +2576,7 @@
           <a:p>
             <a:fld id="{38D1EB97-86F8-4114-AC2B-0DF97BCDEC1A}" type="datetimeFigureOut">
               <a:rPr lang="en-IN" smtClean="0"/>
-              <a:t>21-08-2026</a:t>
+              <a:t>26-08-2026</a:t>
             </a:fld>
             <a:endParaRPr lang="en-IN"/>
           </a:p>
@@ -2760,7 +2889,7 @@
           <a:p>
             <a:fld id="{38D1EB97-86F8-4114-AC2B-0DF97BCDEC1A}" type="datetimeFigureOut">
               <a:rPr lang="en-IN" smtClean="0"/>
-              <a:t>21-08-2026</a:t>
+              <a:t>26-08-2026</a:t>
             </a:fld>
             <a:endParaRPr lang="en-IN"/>
           </a:p>
@@ -3049,7 +3178,7 @@
           <a:p>
             <a:fld id="{38D1EB97-86F8-4114-AC2B-0DF97BCDEC1A}" type="datetimeFigureOut">
               <a:rPr lang="en-IN" smtClean="0"/>
-              <a:t>21-08-2026</a:t>
+              <a:t>26-08-2026</a:t>
             </a:fld>
             <a:endParaRPr lang="en-IN"/>
           </a:p>
@@ -3292,7 +3421,7 @@
           <a:p>
             <a:fld id="{38D1EB97-86F8-4114-AC2B-0DF97BCDEC1A}" type="datetimeFigureOut">
               <a:rPr lang="en-IN" smtClean="0"/>
-              <a:t>21-08-2026</a:t>
+              <a:t>26-08-2026</a:t>
             </a:fld>
             <a:endParaRPr lang="en-IN"/>
           </a:p>
@@ -3940,8 +4069,8 @@
           </a:p>
         </p:txBody>
       </p:sp>
-      <mc:AlternateContent xmlns:mc="http://schemas.openxmlformats.org/markup-compatibility/2006">
-        <mc:Choice xmlns:a14="http://schemas.microsoft.com/office/drawing/2010/main" Requires="a14">
+      <mc:AlternateContent xmlns:mc="http://schemas.openxmlformats.org/markup-compatibility/2006" xmlns:a14="http://schemas.microsoft.com/office/drawing/2010/main">
+        <mc:Choice Requires="a14">
           <p:sp>
             <p:nvSpPr>
               <p:cNvPr id="3" name="Content Placeholder 2">
@@ -3989,31 +4118,39 @@
                     <m:sSub>
                       <m:sSubPr>
                         <m:ctrlPr>
-                          <a:rPr lang="en-IN" sz="1800" i="1"/>
+                          <a:rPr lang="en-IN" sz="1800" i="1">
+                            <a:latin typeface="Cambria Math" panose="02040503050406030204" pitchFamily="18" charset="0"/>
+                          </a:rPr>
                         </m:ctrlPr>
                       </m:sSubPr>
                       <m:e>
                         <m:r>
-                          <a:rPr lang="en-IN" sz="1800" i="1"/>
+                          <a:rPr lang="en-IN" sz="1800" i="1">
+                            <a:latin typeface="Cambria Math" panose="02040503050406030204" pitchFamily="18" charset="0"/>
+                          </a:rPr>
                           <m:t>𝐼</m:t>
                         </m:r>
                       </m:e>
                       <m:sub>
                         <m:r>
-                          <a:rPr lang="en-IN" sz="1800" i="1"/>
+                          <a:rPr lang="en-IN" sz="1800" i="1">
+                            <a:latin typeface="Cambria Math" panose="02040503050406030204" pitchFamily="18" charset="0"/>
+                          </a:rPr>
                           <m:t>𝑙𝑜𝑎𝑑</m:t>
                         </m:r>
                       </m:sub>
                     </m:sSub>
                     <m:r>
-                      <a:rPr lang="en-IN" sz="1800"/>
+                      <a:rPr lang="en-IN" sz="1800">
+                        <a:latin typeface="Cambria Math" panose="02040503050406030204" pitchFamily="18" charset="0"/>
+                      </a:rPr>
                       <m:t>&lt;1.5</m:t>
                     </m:r>
                     <m:r>
                       <m:rPr>
                         <m:nor/>
                       </m:rPr>
-                      <a:rPr lang="en-IN" sz="1800"/>
+                      <a:rPr lang="en-IN" sz="1800" i="0"/>
                       <m:t>A</m:t>
                     </m:r>
                   </m:oMath>
@@ -4035,31 +4172,39 @@
                     <m:sSub>
                       <m:sSubPr>
                         <m:ctrlPr>
-                          <a:rPr lang="en-IN" sz="1800" i="1"/>
+                          <a:rPr lang="en-IN" sz="1800" i="1">
+                            <a:latin typeface="Cambria Math" panose="02040503050406030204" pitchFamily="18" charset="0"/>
+                          </a:rPr>
                         </m:ctrlPr>
                       </m:sSubPr>
                       <m:e>
                         <m:r>
-                          <a:rPr lang="en-IN" sz="1800" i="1"/>
+                          <a:rPr lang="en-IN" sz="1800" i="1">
+                            <a:latin typeface="Cambria Math" panose="02040503050406030204" pitchFamily="18" charset="0"/>
+                          </a:rPr>
                           <m:t>𝐼</m:t>
                         </m:r>
                       </m:e>
                       <m:sub>
                         <m:r>
-                          <a:rPr lang="en-IN" sz="1800" i="1"/>
+                          <a:rPr lang="en-IN" sz="1800" i="1">
+                            <a:latin typeface="Cambria Math" panose="02040503050406030204" pitchFamily="18" charset="0"/>
+                          </a:rPr>
                           <m:t>𝑟𝑎𝑤</m:t>
                         </m:r>
                       </m:sub>
                     </m:sSub>
                     <m:r>
-                      <a:rPr lang="en-IN" sz="1800"/>
+                      <a:rPr lang="en-IN" sz="1800">
+                        <a:latin typeface="Cambria Math" panose="02040503050406030204" pitchFamily="18" charset="0"/>
+                      </a:rPr>
                       <m:t>&lt;1.5</m:t>
                     </m:r>
                     <m:r>
                       <m:rPr>
                         <m:nor/>
                       </m:rPr>
-                      <a:rPr lang="en-IN" sz="1800"/>
+                      <a:rPr lang="en-IN" sz="1800" i="0"/>
                       <m:t>A</m:t>
                     </m:r>
                   </m:oMath>
@@ -4080,41 +4225,55 @@
                     <m:sSub>
                       <m:sSubPr>
                         <m:ctrlPr>
-                          <a:rPr lang="en-IN" sz="1800" i="1"/>
+                          <a:rPr lang="en-IN" sz="1800" i="1">
+                            <a:latin typeface="Cambria Math" panose="02040503050406030204" pitchFamily="18" charset="0"/>
+                          </a:rPr>
                         </m:ctrlPr>
                       </m:sSubPr>
                       <m:e>
                         <m:r>
-                          <a:rPr lang="en-IN" sz="1800" i="1"/>
+                          <a:rPr lang="en-IN" sz="1800" i="1">
+                            <a:latin typeface="Cambria Math" panose="02040503050406030204" pitchFamily="18" charset="0"/>
+                          </a:rPr>
                           <m:t>𝐼</m:t>
                         </m:r>
                       </m:e>
                       <m:sub>
                         <m:r>
-                          <a:rPr lang="en-IN" sz="1800" i="1"/>
+                          <a:rPr lang="en-IN" sz="1800" i="1">
+                            <a:latin typeface="Cambria Math" panose="02040503050406030204" pitchFamily="18" charset="0"/>
+                          </a:rPr>
                           <m:t>𝑟𝑒𝑓</m:t>
                         </m:r>
                       </m:sub>
                     </m:sSub>
                     <m:r>
-                      <a:rPr lang="en-IN" sz="1800"/>
+                      <a:rPr lang="en-IN" sz="1800">
+                        <a:latin typeface="Cambria Math" panose="02040503050406030204" pitchFamily="18" charset="0"/>
+                      </a:rPr>
                       <m:t>=</m:t>
                     </m:r>
                     <m:sSub>
                       <m:sSubPr>
                         <m:ctrlPr>
-                          <a:rPr lang="en-IN" sz="1800" i="1"/>
+                          <a:rPr lang="en-IN" sz="1800" i="1">
+                            <a:latin typeface="Cambria Math" panose="02040503050406030204" pitchFamily="18" charset="0"/>
+                          </a:rPr>
                         </m:ctrlPr>
                       </m:sSubPr>
                       <m:e>
                         <m:r>
-                          <a:rPr lang="en-IN" sz="1800" i="1"/>
+                          <a:rPr lang="en-IN" sz="1800" i="1">
+                            <a:latin typeface="Cambria Math" panose="02040503050406030204" pitchFamily="18" charset="0"/>
+                          </a:rPr>
                           <m:t>𝐼</m:t>
                         </m:r>
                       </m:e>
                       <m:sub>
                         <m:r>
-                          <a:rPr lang="en-IN" sz="1800" i="1"/>
+                          <a:rPr lang="en-IN" sz="1800" i="1">
+                            <a:latin typeface="Cambria Math" panose="02040503050406030204" pitchFamily="18" charset="0"/>
+                          </a:rPr>
                           <m:t>𝑟𝑎𝑤</m:t>
                         </m:r>
                       </m:sub>
@@ -4135,14 +4294,16 @@
                 <a14:m>
                   <m:oMath xmlns:m="http://schemas.openxmlformats.org/officeDocument/2006/math">
                     <m:r>
-                      <a:rPr lang="en-IN" sz="1800"/>
+                      <a:rPr lang="en-IN" sz="1800">
+                        <a:latin typeface="Cambria Math" panose="02040503050406030204" pitchFamily="18" charset="0"/>
+                      </a:rPr>
                       <m:t>5.000</m:t>
                     </m:r>
                     <m:r>
                       <m:rPr>
                         <m:nor/>
                       </m:rPr>
-                      <a:rPr lang="en-IN" sz="1800"/>
+                      <a:rPr lang="en-IN" sz="1800" i="0"/>
                       <m:t>V</m:t>
                     </m:r>
                   </m:oMath>
@@ -4166,31 +4327,39 @@
                     <m:sSub>
                       <m:sSubPr>
                         <m:ctrlPr>
-                          <a:rPr lang="en-IN" sz="1800" i="1"/>
+                          <a:rPr lang="en-IN" sz="1800" i="1">
+                            <a:latin typeface="Cambria Math" panose="02040503050406030204" pitchFamily="18" charset="0"/>
+                          </a:rPr>
                         </m:ctrlPr>
                       </m:sSubPr>
                       <m:e>
                         <m:r>
-                          <a:rPr lang="en-IN" sz="1800" i="1"/>
+                          <a:rPr lang="en-IN" sz="1800" i="1">
+                            <a:latin typeface="Cambria Math" panose="02040503050406030204" pitchFamily="18" charset="0"/>
+                          </a:rPr>
                           <m:t>𝐼</m:t>
                         </m:r>
                       </m:e>
                       <m:sub>
                         <m:r>
-                          <a:rPr lang="en-IN" sz="1800" i="1"/>
+                          <a:rPr lang="en-IN" sz="1800" i="1">
+                            <a:latin typeface="Cambria Math" panose="02040503050406030204" pitchFamily="18" charset="0"/>
+                          </a:rPr>
                           <m:t>𝑙𝑜𝑎𝑑</m:t>
                         </m:r>
                       </m:sub>
                     </m:sSub>
                     <m:r>
-                      <a:rPr lang="en-IN" sz="1800"/>
+                      <a:rPr lang="en-IN" sz="1800">
+                        <a:latin typeface="Cambria Math" panose="02040503050406030204" pitchFamily="18" charset="0"/>
+                      </a:rPr>
                       <m:t>≥1.5</m:t>
                     </m:r>
                     <m:r>
                       <m:rPr>
                         <m:nor/>
                       </m:rPr>
-                      <a:rPr lang="en-IN" sz="1800"/>
+                      <a:rPr lang="en-IN" sz="1800" i="0"/>
                       <m:t>A</m:t>
                     </m:r>
                   </m:oMath>
@@ -4212,18 +4381,24 @@
                     <m:sSub>
                       <m:sSubPr>
                         <m:ctrlPr>
-                          <a:rPr lang="en-IN" sz="1800" i="1"/>
+                          <a:rPr lang="en-IN" sz="1800" i="1">
+                            <a:latin typeface="Cambria Math" panose="02040503050406030204" pitchFamily="18" charset="0"/>
+                          </a:rPr>
                         </m:ctrlPr>
                       </m:sSubPr>
                       <m:e>
                         <m:r>
-                          <a:rPr lang="en-IN" sz="1800" i="1"/>
+                          <a:rPr lang="en-IN" sz="1800" i="1">
+                            <a:latin typeface="Cambria Math" panose="02040503050406030204" pitchFamily="18" charset="0"/>
+                          </a:rPr>
                           <m:t>𝑉</m:t>
                         </m:r>
                       </m:e>
                       <m:sub>
                         <m:r>
-                          <a:rPr lang="en-IN" sz="1800" i="1"/>
+                          <a:rPr lang="en-IN" sz="1800" i="1">
+                            <a:latin typeface="Cambria Math" panose="02040503050406030204" pitchFamily="18" charset="0"/>
+                          </a:rPr>
                           <m:t>𝑜𝑢𝑡</m:t>
                         </m:r>
                       </m:sub>
@@ -4239,31 +4414,39 @@
                     <m:sSub>
                       <m:sSubPr>
                         <m:ctrlPr>
-                          <a:rPr lang="en-IN" sz="1800" i="1"/>
+                          <a:rPr lang="en-IN" sz="1800" i="1">
+                            <a:latin typeface="Cambria Math" panose="02040503050406030204" pitchFamily="18" charset="0"/>
+                          </a:rPr>
                         </m:ctrlPr>
                       </m:sSubPr>
                       <m:e>
                         <m:r>
-                          <a:rPr lang="en-IN" sz="1800" i="1"/>
+                          <a:rPr lang="en-IN" sz="1800" i="1">
+                            <a:latin typeface="Cambria Math" panose="02040503050406030204" pitchFamily="18" charset="0"/>
+                          </a:rPr>
                           <m:t>𝐼</m:t>
                         </m:r>
                       </m:e>
                       <m:sub>
                         <m:r>
-                          <a:rPr lang="en-IN" sz="1800" i="1"/>
+                          <a:rPr lang="en-IN" sz="1800" i="1">
+                            <a:latin typeface="Cambria Math" panose="02040503050406030204" pitchFamily="18" charset="0"/>
+                          </a:rPr>
                           <m:t>𝑟𝑎𝑤</m:t>
                         </m:r>
                       </m:sub>
                     </m:sSub>
                     <m:r>
-                      <a:rPr lang="en-IN" sz="1800"/>
+                      <a:rPr lang="en-IN" sz="1800">
+                        <a:latin typeface="Cambria Math" panose="02040503050406030204" pitchFamily="18" charset="0"/>
+                      </a:rPr>
                       <m:t>&gt;1.5</m:t>
                     </m:r>
                     <m:r>
                       <m:rPr>
                         <m:nor/>
                       </m:rPr>
-                      <a:rPr lang="en-IN" sz="1800"/>
+                      <a:rPr lang="en-IN" sz="1800" i="0"/>
                       <m:t>A</m:t>
                     </m:r>
                   </m:oMath>
@@ -4284,31 +4467,39 @@
                     <m:sSub>
                       <m:sSubPr>
                         <m:ctrlPr>
-                          <a:rPr lang="en-IN" sz="1800" i="1"/>
+                          <a:rPr lang="en-IN" sz="1800" i="1">
+                            <a:latin typeface="Cambria Math" panose="02040503050406030204" pitchFamily="18" charset="0"/>
+                          </a:rPr>
                         </m:ctrlPr>
                       </m:sSubPr>
                       <m:e>
                         <m:r>
-                          <a:rPr lang="en-IN" sz="1800" i="1"/>
+                          <a:rPr lang="en-IN" sz="1800" i="1">
+                            <a:latin typeface="Cambria Math" panose="02040503050406030204" pitchFamily="18" charset="0"/>
+                          </a:rPr>
                           <m:t>𝐼</m:t>
                         </m:r>
                       </m:e>
                       <m:sub>
                         <m:r>
-                          <a:rPr lang="en-IN" sz="1800" i="1"/>
+                          <a:rPr lang="en-IN" sz="1800" i="1">
+                            <a:latin typeface="Cambria Math" panose="02040503050406030204" pitchFamily="18" charset="0"/>
+                          </a:rPr>
                           <m:t>𝑟𝑒𝑓</m:t>
                         </m:r>
                       </m:sub>
                     </m:sSub>
                     <m:r>
-                      <a:rPr lang="en-IN" sz="1800"/>
+                      <a:rPr lang="en-IN" sz="1800">
+                        <a:latin typeface="Cambria Math" panose="02040503050406030204" pitchFamily="18" charset="0"/>
+                      </a:rPr>
                       <m:t>=1.500</m:t>
                     </m:r>
                     <m:r>
                       <m:rPr>
                         <m:nor/>
                       </m:rPr>
-                      <a:rPr lang="en-IN" sz="1800"/>
+                      <a:rPr lang="en-IN" sz="1800" i="0"/>
                       <m:t>A</m:t>
                     </m:r>
                   </m:oMath>
@@ -4329,31 +4520,39 @@
                     <m:sSub>
                       <m:sSubPr>
                         <m:ctrlPr>
-                          <a:rPr lang="en-IN" sz="1800" i="1"/>
+                          <a:rPr lang="en-IN" sz="1800" i="1">
+                            <a:latin typeface="Cambria Math" panose="02040503050406030204" pitchFamily="18" charset="0"/>
+                          </a:rPr>
                         </m:ctrlPr>
                       </m:sSubPr>
                       <m:e>
                         <m:r>
-                          <a:rPr lang="en-IN" sz="1800" i="1"/>
+                          <a:rPr lang="en-IN" sz="1800" i="1">
+                            <a:latin typeface="Cambria Math" panose="02040503050406030204" pitchFamily="18" charset="0"/>
+                          </a:rPr>
                           <m:t>𝐼</m:t>
                         </m:r>
                       </m:e>
                       <m:sub>
                         <m:r>
-                          <a:rPr lang="en-IN" sz="1800" i="1"/>
+                          <a:rPr lang="en-IN" sz="1800" i="1">
+                            <a:latin typeface="Cambria Math" panose="02040503050406030204" pitchFamily="18" charset="0"/>
+                          </a:rPr>
                           <m:t>𝐿</m:t>
                         </m:r>
                       </m:sub>
                     </m:sSub>
                     <m:r>
-                      <a:rPr lang="en-IN" sz="1800"/>
+                      <a:rPr lang="en-IN" sz="1800">
+                        <a:latin typeface="Cambria Math" panose="02040503050406030204" pitchFamily="18" charset="0"/>
+                      </a:rPr>
                       <m:t>=1.500</m:t>
                     </m:r>
                     <m:r>
                       <m:rPr>
                         <m:nor/>
                       </m:rPr>
-                      <a:rPr lang="en-IN" sz="1800"/>
+                      <a:rPr lang="en-IN" sz="1800" i="0"/>
                       <m:t>A</m:t>
                     </m:r>
                   </m:oMath>
@@ -4378,7 +4577,7 @@
             </p:txBody>
           </p:sp>
         </mc:Choice>
-        <mc:Fallback>
+        <mc:Fallback xmlns="">
           <p:sp>
             <p:nvSpPr>
               <p:cNvPr id="3" name="Content Placeholder 2">
@@ -4454,10 +4653,10 @@
       </p:grpSpPr>
       <p:pic>
         <p:nvPicPr>
-          <p:cNvPr id="5" name="Picture 4">
-            <a:extLst>
-              <a:ext uri="{FF2B5EF4-FFF2-40B4-BE49-F238E27FC236}">
-                <a16:creationId xmlns:a16="http://schemas.microsoft.com/office/drawing/2014/main" id="{374806D8-A4D2-D3DC-5CB8-AA81E0E0891B}"/>
+          <p:cNvPr id="3" name="Picture 2">
+            <a:extLst>
+              <a:ext uri="{FF2B5EF4-FFF2-40B4-BE49-F238E27FC236}">
+                <a16:creationId xmlns:a16="http://schemas.microsoft.com/office/drawing/2014/main" id="{71D159D8-857C-1612-EB5F-5694F115D5A2}"/>
               </a:ext>
             </a:extLst>
           </p:cNvPr>
@@ -4474,74 +4673,49 @@
         </p:blipFill>
         <p:spPr>
           <a:xfrm>
-            <a:off x="2314047" y="166232"/>
-            <a:ext cx="7459116" cy="2181529"/>
+            <a:off x="538181" y="0"/>
+            <a:ext cx="11115638" cy="5426313"/>
           </a:xfrm>
           <a:prstGeom prst="rect">
             <a:avLst/>
           </a:prstGeom>
         </p:spPr>
       </p:pic>
-      <p:pic>
-        <p:nvPicPr>
-          <p:cNvPr id="7" name="Picture 6">
-            <a:extLst>
-              <a:ext uri="{FF2B5EF4-FFF2-40B4-BE49-F238E27FC236}">
-                <a16:creationId xmlns:a16="http://schemas.microsoft.com/office/drawing/2014/main" id="{C2D3265C-6CEB-F4D7-45EA-5124C7CE2218}"/>
-              </a:ext>
-            </a:extLst>
-          </p:cNvPr>
-          <p:cNvPicPr>
-            <a:picLocks noChangeAspect="1"/>
-          </p:cNvPicPr>
+      <p:sp>
+        <p:nvSpPr>
+          <p:cNvPr id="8" name="TextBox 7">
+            <a:extLst>
+              <a:ext uri="{FF2B5EF4-FFF2-40B4-BE49-F238E27FC236}">
+                <a16:creationId xmlns:a16="http://schemas.microsoft.com/office/drawing/2014/main" id="{1FFEF2B4-8A3E-CAA0-E7EB-10F10E198A50}"/>
+              </a:ext>
+            </a:extLst>
+          </p:cNvPr>
+          <p:cNvSpPr txBox="1"/>
           <p:nvPr/>
-        </p:nvPicPr>
-        <p:blipFill>
-          <a:blip r:embed="rId3"/>
-          <a:stretch>
-            <a:fillRect/>
-          </a:stretch>
-        </p:blipFill>
+        </p:nvSpPr>
         <p:spPr>
           <a:xfrm>
-            <a:off x="2314047" y="2347763"/>
-            <a:ext cx="7459116" cy="2162477"/>
+            <a:off x="1033272" y="5568696"/>
+            <a:ext cx="9875520" cy="923330"/>
           </a:xfrm>
           <a:prstGeom prst="rect">
             <a:avLst/>
           </a:prstGeom>
+          <a:noFill/>
         </p:spPr>
-      </p:pic>
-      <p:pic>
-        <p:nvPicPr>
-          <p:cNvPr id="9" name="Picture 8">
-            <a:extLst>
-              <a:ext uri="{FF2B5EF4-FFF2-40B4-BE49-F238E27FC236}">
-                <a16:creationId xmlns:a16="http://schemas.microsoft.com/office/drawing/2014/main" id="{1A637697-2FB7-FD0E-7BB8-CFD1830432F8}"/>
-              </a:ext>
-            </a:extLst>
-          </p:cNvPr>
-          <p:cNvPicPr>
-            <a:picLocks noChangeAspect="1"/>
-          </p:cNvPicPr>
-          <p:nvPr/>
-        </p:nvPicPr>
-        <p:blipFill>
-          <a:blip r:embed="rId4"/>
-          <a:stretch>
-            <a:fillRect/>
-          </a:stretch>
-        </p:blipFill>
-        <p:spPr>
-          <a:xfrm>
-            <a:off x="2314047" y="4510240"/>
-            <a:ext cx="7459116" cy="1799120"/>
-          </a:xfrm>
-          <a:prstGeom prst="rect">
-            <a:avLst/>
-          </a:prstGeom>
-        </p:spPr>
-      </p:pic>
+        <p:txBody>
+          <a:bodyPr wrap="square" rtlCol="0">
+            <a:spAutoFit/>
+          </a:bodyPr>
+          <a:lstStyle/>
+          <a:p>
+            <a:r>
+              <a:rPr lang="en-IN" dirty="0"/>
+              <a:t>Source: A Cascaded Synchronous Buck Converter for Light Electric Vehicle Charging Applications Mohammad Faisal Akhtar1, Siti Rohani Sheikh Raihan1, Nasrudin Abdul Rahim1, Mohd Khairil Rahmat2* </a:t>
+            </a:r>
+          </a:p>
+        </p:txBody>
+      </p:sp>
     </p:spTree>
     <p:extLst>
       <p:ext uri="{BB962C8B-B14F-4D97-AF65-F5344CB8AC3E}">
@@ -4574,10 +4748,10 @@
       </p:grpSpPr>
       <p:pic>
         <p:nvPicPr>
-          <p:cNvPr id="3" name="Picture 2">
-            <a:extLst>
-              <a:ext uri="{FF2B5EF4-FFF2-40B4-BE49-F238E27FC236}">
-                <a16:creationId xmlns:a16="http://schemas.microsoft.com/office/drawing/2014/main" id="{B623D55B-B264-8050-306D-657136DF845B}"/>
+          <p:cNvPr id="4" name="Picture 3">
+            <a:extLst>
+              <a:ext uri="{FF2B5EF4-FFF2-40B4-BE49-F238E27FC236}">
+                <a16:creationId xmlns:a16="http://schemas.microsoft.com/office/drawing/2014/main" id="{8524C895-0949-B225-A45D-A995C7E873A5}"/>
               </a:ext>
             </a:extLst>
           </p:cNvPr>
@@ -4594,74 +4768,49 @@
         </p:blipFill>
         <p:spPr>
           <a:xfrm>
-            <a:off x="2385494" y="302357"/>
-            <a:ext cx="7421011" cy="2248214"/>
+            <a:off x="1061335" y="784010"/>
+            <a:ext cx="10069330" cy="3991532"/>
           </a:xfrm>
           <a:prstGeom prst="rect">
             <a:avLst/>
           </a:prstGeom>
         </p:spPr>
       </p:pic>
-      <p:pic>
-        <p:nvPicPr>
-          <p:cNvPr id="5" name="Picture 4">
-            <a:extLst>
-              <a:ext uri="{FF2B5EF4-FFF2-40B4-BE49-F238E27FC236}">
-                <a16:creationId xmlns:a16="http://schemas.microsoft.com/office/drawing/2014/main" id="{78A43E04-ADA9-BCC4-BA00-8F71ED898328}"/>
-              </a:ext>
-            </a:extLst>
-          </p:cNvPr>
-          <p:cNvPicPr>
-            <a:picLocks noChangeAspect="1"/>
-          </p:cNvPicPr>
+      <p:sp>
+        <p:nvSpPr>
+          <p:cNvPr id="6" name="TextBox 5">
+            <a:extLst>
+              <a:ext uri="{FF2B5EF4-FFF2-40B4-BE49-F238E27FC236}">
+                <a16:creationId xmlns:a16="http://schemas.microsoft.com/office/drawing/2014/main" id="{8512C559-C20A-D34F-B82D-3262DF06B04A}"/>
+              </a:ext>
+            </a:extLst>
+          </p:cNvPr>
+          <p:cNvSpPr txBox="1"/>
           <p:nvPr/>
-        </p:nvPicPr>
-        <p:blipFill>
-          <a:blip r:embed="rId3"/>
-          <a:stretch>
-            <a:fillRect/>
-          </a:stretch>
-        </p:blipFill>
+        </p:nvSpPr>
         <p:spPr>
           <a:xfrm>
-            <a:off x="2385494" y="2550571"/>
-            <a:ext cx="7421010" cy="2219635"/>
+            <a:off x="1444752" y="5413248"/>
+            <a:ext cx="9875520" cy="923330"/>
           </a:xfrm>
           <a:prstGeom prst="rect">
             <a:avLst/>
           </a:prstGeom>
+          <a:noFill/>
         </p:spPr>
-      </p:pic>
-      <p:pic>
-        <p:nvPicPr>
-          <p:cNvPr id="7" name="Picture 6">
-            <a:extLst>
-              <a:ext uri="{FF2B5EF4-FFF2-40B4-BE49-F238E27FC236}">
-                <a16:creationId xmlns:a16="http://schemas.microsoft.com/office/drawing/2014/main" id="{1575AAE5-9134-DC1D-7204-E4E1A8596AA5}"/>
-              </a:ext>
-            </a:extLst>
-          </p:cNvPr>
-          <p:cNvPicPr>
-            <a:picLocks noChangeAspect="1"/>
-          </p:cNvPicPr>
-          <p:nvPr/>
-        </p:nvPicPr>
-        <p:blipFill>
-          <a:blip r:embed="rId4"/>
-          <a:stretch>
-            <a:fillRect/>
-          </a:stretch>
-        </p:blipFill>
-        <p:spPr>
-          <a:xfrm>
-            <a:off x="2385492" y="4733629"/>
-            <a:ext cx="7421009" cy="1822013"/>
-          </a:xfrm>
-          <a:prstGeom prst="rect">
-            <a:avLst/>
-          </a:prstGeom>
-        </p:spPr>
-      </p:pic>
+        <p:txBody>
+          <a:bodyPr wrap="square" rtlCol="0">
+            <a:spAutoFit/>
+          </a:bodyPr>
+          <a:lstStyle/>
+          <a:p>
+            <a:r>
+              <a:rPr lang="en-IN" dirty="0"/>
+              <a:t>Source: A Cascaded Synchronous Buck Converter for Light Electric Vehicle Charging Applications Mohammad Faisal Akhtar1, Siti Rohani Sheikh Raihan1, Nasrudin Abdul Rahim1, Mohd Khairil Rahmat2* </a:t>
+            </a:r>
+          </a:p>
+        </p:txBody>
+      </p:sp>
     </p:spTree>
     <p:extLst>
       <p:ext uri="{BB962C8B-B14F-4D97-AF65-F5344CB8AC3E}">
@@ -5024,8 +5173,8 @@
           <a:chExt cx="0" cy="0"/>
         </a:xfrm>
       </p:grpSpPr>
-      <mc:AlternateContent xmlns:mc="http://schemas.openxmlformats.org/markup-compatibility/2006">
-        <mc:Choice xmlns:a14="http://schemas.microsoft.com/office/drawing/2010/main" Requires="a14">
+      <mc:AlternateContent xmlns:mc="http://schemas.openxmlformats.org/markup-compatibility/2006" xmlns:a14="http://schemas.microsoft.com/office/drawing/2010/main">
+        <mc:Choice Requires="a14">
           <p:sp>
             <p:nvSpPr>
               <p:cNvPr id="4" name="TextBox 3">
@@ -5221,7 +5370,9 @@
                       </m:e>
                       <m:sup>
                         <m:r>
-                          <a:rPr lang="en-IN" sz="1600" b="0" i="1"/>
+                          <a:rPr lang="en-IN" sz="1600" b="0" i="1">
+                            <a:latin typeface="Cambria Math" panose="02040503050406030204" pitchFamily="18" charset="0"/>
+                          </a:rPr>
                           <m:t>𝜆</m:t>
                         </m:r>
                       </m:sup>
@@ -5261,7 +5412,7 @@
             </p:txBody>
           </p:sp>
         </mc:Choice>
-        <mc:Fallback>
+        <mc:Fallback xmlns="">
           <p:sp>
             <p:nvSpPr>
               <p:cNvPr id="4" name="TextBox 3">
@@ -6408,8 +6559,8 @@
           </a:p>
         </p:txBody>
       </p:sp>
-      <mc:AlternateContent xmlns:mc="http://schemas.openxmlformats.org/markup-compatibility/2006">
-        <mc:Choice xmlns:a14="http://schemas.microsoft.com/office/drawing/2010/main" Requires="a14">
+      <mc:AlternateContent xmlns:mc="http://schemas.openxmlformats.org/markup-compatibility/2006" xmlns:a14="http://schemas.microsoft.com/office/drawing/2010/main">
+        <mc:Choice Requires="a14">
           <p:sp>
             <p:nvSpPr>
               <p:cNvPr id="5" name="Content Placeholder 4">
@@ -6456,14 +6607,16 @@
                 <a14:m>
                   <m:oMath xmlns:m="http://schemas.openxmlformats.org/officeDocument/2006/math">
                     <m:r>
-                      <a:rPr lang="en-IN" sz="2600"/>
+                      <a:rPr lang="en-IN" sz="2600">
+                        <a:latin typeface="Cambria Math" panose="02040503050406030204" pitchFamily="18" charset="0"/>
+                      </a:rPr>
                       <m:t>2</m:t>
                     </m:r>
                     <m:r>
                       <m:rPr>
                         <m:nor/>
                       </m:rPr>
-                      <a:rPr lang="en-IN" sz="2600"/>
+                      <a:rPr lang="en-IN" sz="2600" i="0"/>
                       <m:t>A</m:t>
                     </m:r>
                   </m:oMath>
@@ -6489,7 +6642,7 @@
             </p:txBody>
           </p:sp>
         </mc:Choice>
-        <mc:Fallback>
+        <mc:Fallback xmlns="">
           <p:sp>
             <p:nvSpPr>
               <p:cNvPr id="5" name="Content Placeholder 4">

</xml_diff>